<commit_message>
Round 3 fixes for L4: the Editor's Chair gets a real turn order (Speaker 1 named, the minute run twice) on worksheet, plan and slide; blocks resplit so the notes and revision have time to be written; page 2's two-inch dead band now carries the protocol and a third line per note; ISTE 1.6.b replaced by 1.1.c because a paper lesson remixes no digital resources; the spot art's heart no longer draws behind the page; cover sub and kicker carry the payoff
Co-Authored-By: Claude Opus 5 <noreply@anthropic.com>
Claude-Session: https://claude.ai/code/session_01VWaJFc84eoA3U4f2VjTKjw
</commit_message>
<xml_diff>
--- a/products/ai-taste-file/dist/Teach AI Your Taste - Slides.pptx
+++ b/products/ai-taste-file/dist/Teach AI Your Taste - Slides.pptx
@@ -602,7 +602,7 @@
           <a:p>
             <a:r>
               <a:rPr lang="en-US" dirty="0"/>
-              <a:t>This is the SL.6.1 moment. Sample 3–4 pairs: listen for the answer to cite a section ("Section 3 says no textbook words"), not the editor's own taste ("I'd just make it funnier"). WHAT IF the writer argues back: "Ask which sentence, not whether." Both check checklist row 4 on page 3 afterwards.</a:t>
+              <a:t>This is the SL.6.1 moment, and the turn order is what makes it one: every student reads notes aloud AND asks a question. Same text is printed on worksheet page 2, with the two question frames — "Which sentence?" or "What would fit?" Sample 3–4 pairs: listen for the answer to cite a section ("Section 3 says no textbook words"), not the editor's own taste ("I'd just make it funnier"). WHAT IF a pair can't tell who is Speaker 1: "Whose name starts closer to A?" WHAT IF the writer argues back: "Ask which sentence, not whether." Both check checklist row 4 on page 3 afterwards.</a:t>
             </a:r>
             <a:endParaRPr lang="en-US" dirty="0"/>
           </a:p>
@@ -690,7 +690,7 @@
           <a:p>
             <a:r>
               <a:rPr lang="en-US" dirty="0"/>
-              <a:t>Page 3, after the revision. Students check all four before the Last Check. Rows 1 and 3 verify ISTE 1.6.b (own draft, own revision — check against the handwriting and the stars); row 4 verifies the talk you sampled. WHAT IF a student changed nothing: "Your editor pointed at section 3. Read that section out loud. Now change one sentence to match it." TRANSITION: "Checklist — four checks. Then the Last Check at the bottom: three answers, your own words, four minutes."</a:t>
+              <a:t>Page 3, after the revision. Students check all four before the Last Check. Rows 1 and 3 verify the human at both ends (own draft, own revision — check against the handwriting and the stars); row 4 verifies the talk you sampled. WHAT IF a student changed nothing: "Your editor pointed at section 3. Read that section out loud. Now change one sentence to match it." TRANSITION: "Checklist — four checks. Then the Last Check at the bottom: three answers, your own words, five minutes."</a:t>
             </a:r>
             <a:endParaRPr lang="en-US" dirty="0"/>
           </a:p>
@@ -778,7 +778,7 @@
           <a:p>
             <a:r>
               <a:rPr lang="en-US" dirty="0"/>
-              <a:t>Solo, 4 minutes. Collect. KEY — #1: quotes the old words and the new words ("I made it funnier" without the words = redo). #2: names a section and the match: "Section 1 says blunt; the new line is blunt." #3 (Objective 1): proficient = "make it better" names no sentence and no direction — better for whom? — while the real note named a section and a sentence. Jaylen exemplar: "'I enjoy various hobbies' → 'I lose at games and cook worse.' Section 3 says no textbook words. 'Make it better' doesn't say what's wrong or what better means for ME." WHAT IF "I made it better": "Which word changed? Write the old word and the new one."</a:t>
+              <a:t>Solo, 5 minutes. Collect. KEY — #1: names one word or phrase and gives it both ways, old → new ("I made it funnier" without the words = redo). #2: names a section and the match: "Section 1 says blunt; the new line is blunt." #3 (Objective 1): proficient = "make it better" names no sentence and no direction — better for whom? — while the real note named a section and a sentence. Jaylen exemplar: "'I enjoy various hobbies' → 'I lose at games and cook worse.' Section 3 says no textbook words. 'Make it better' doesn't say what's wrong or what better means for ME." WHAT IF "I made it better": "Which word changed? Write the old word and the new one."</a:t>
             </a:r>
             <a:endParaRPr lang="en-US" dirty="0"/>
           </a:p>
@@ -1042,7 +1042,7 @@
           <a:p>
             <a:r>
               <a:rPr lang="en-US" dirty="0"/>
-              <a:t>ANSWER (say it, don't show it): the same way the feed did — you teach it. Bridge, verbatim: "Here's the other side. Unless you tell it — or it has saved notes about you — an AI doesn't know your taste. Today you write your taste down on one page, and then you use it to make YOUR OWN writing better." TRANSITION: "So what happens when the editor knows nothing about you? Watch."</a:t>
+              <a:t>ANSWER (say it, don't show it): the same way the feed did — you teach it. Bridge, verbatim: "Here's the other side. An AI doesn't know your taste unless you tell it, or it has saved notes about you. Today you write your taste down on one page, and then you use it to make YOUR OWN writing better." TRANSITION: "So what happens when the editor knows nothing about you? Watch."</a:t>
             </a:r>
             <a:endParaRPr lang="en-US" dirty="0"/>
           </a:p>
@@ -1218,7 +1218,7 @@
           <a:p>
             <a:r>
               <a:rPr lang="en-US" dirty="0"/>
-              <a:t>Ask: which note could you actually act on? The right-hand note points at the writer's own taste file — that's the whole difference between a note for a generic writer and an editor's note. WHAT IF 'the AI I use already knows me': 'Some tools do save notes about you. A fresh chat usually doesn't — and either way, a taste file is the fastest way to make sure the notes fit.'</a:t>
+              <a:t>Read the draft aloud first, then both notes. Ask: which note could you actually act on? The generic note fits any writer. The taste-file note names sentence 2 and points at the writer's own file — that's the whole difference. WHAT IF 'the AI I use already knows me': 'Some tools do save notes about you. A fresh chat usually doesn't — and either way, a taste file is the fastest way to make sure the notes fit.'</a:t>
             </a:r>
             <a:endParaRPr lang="en-US" dirty="0"/>
           </a:p>
@@ -1306,7 +1306,7 @@
           <a:p>
             <a:r>
               <a:rPr lang="en-US" dirty="0"/>
-              <a:t>Say it plainly: a ghostwriter writes it for you and lets you put your name on it. Today, nobody in this room is a ghostwriter — not a partner, not an AI. Then move on. TRANSITION: "Page 1. Your taste, written down — five sections, twelve minutes, solo. Nobody swaps anything yet."</a:t>
+              <a:t>Say it plainly: a ghostwriter writes it for you and lets you put your name on it. Today, nobody in this room is a ghostwriter — not a partner, not an AI. Then move on. TRANSITION: "Page 1. Your taste, written down — five sections, ten minutes, solo. Nobody swaps anything yet."</a:t>
             </a:r>
             <a:endParaRPr lang="en-US" dirty="0"/>
           </a:p>
@@ -1394,7 +1394,7 @@
           <a:p>
             <a:r>
               <a:rPr lang="en-US" dirty="0"/>
-              <a:t>Solo on worksheet page 1. Circulate and push for specifics: "quiet" beats "good"; "don't make me sound like a textbook" beats "be nice." WHAT IF stuck on So Me: "Read me the last text you sent a friend. That's your voice." Minute 10: two volunteers read a So Me sentence — the class hears how different real taste sounds. TRANSITION: "Flip to page 2. Three to four sentences: the About Me for a channel or profile you'd really make. Match your taste file. Solo — five minutes."</a:t>
+              <a:t>Solo on worksheet page 1. Circulate and push for specifics: "quiet" beats "good"; "don't make me sound like a textbook" beats "be nice." WHAT IF stuck on So Me: "Read me the last text you sent a friend. That's your voice." Minute 8: two volunteers read a So Me sentence — the class hears how different real taste sounds. TRANSITION: "Flip to page 2. Three to four sentences: the About Me for a channel or profile you'd really make. Match your taste file. Solo — five minutes."</a:t>
             </a:r>
             <a:endParaRPr lang="en-US" dirty="0"/>
           </a:p>
@@ -1482,7 +1482,7 @@
           <a:p>
             <a:r>
               <a:rPr lang="en-US" dirty="0"/>
-              <a:t>DRAFT — WHAT IF 'I don't have a channel': "The one you WOULD make — a game name, a team, a club, a pet's account." TRANSITION: "Pens down. Swap ALL your pages with your partner. You are now their editor — and page 1 is the only thing you're allowed to know about them." NOTES (3 min writing): put the next slide up. WHAT IF the editor rewrites: "You're the editor. Hand the pen back." No section number: "Which section? No section, no note." With devices: run Step 2 once on YOUR projected account — one volunteer's taste file and draft in the copy-ready prompt (Teacher Guide) — and the class checks whether each note names a section. Students never need an account. TRANSITION at 3 min: "Editors, pens down. Read your two notes out loud to your writer. Writers, one question." Then: "Swap back. Page 3 — your draft, your pen. Star every change."</a:t>
+              <a:t>DRAFT — WHAT IF 'I don't have a channel': "The one you WOULD make — a game name, a team, a club, a pet's account." TRANSITION: "Pens down. Swap ALL your pages with your partner. You are now their editor — and page 1 is the only thing you're allowed to know about them." NOTES (4 min writing): put the next slide up. WHAT IF the editor rewrites: "You're the editor. Hand the pen back." No section number: "Which section? No section, no note." With devices: run Step 2 once on YOUR projected account — one volunteer's taste file and draft in the copy-ready prompt (Teacher Guide) — and the class checks whether each note names a section. Students never need an account. TRANSITION after the 4 minutes of writing: "Speaker 1, you are the editor first — read your two notes out loud. Writers, one question." At the one-minute call: "Switch. Speaker 2 runs the same minute." Then: "Swap back. Page 3 — your draft, your pen. Star every change."</a:t>
             </a:r>
             <a:endParaRPr lang="en-US" dirty="0"/>
           </a:p>
@@ -2305,7 +2305,7 @@
                 <a:ea typeface="Arial" pitchFamily="34" charset="-122"/>
                 <a:cs typeface="Arial" pitchFamily="34" charset="-120"/>
               </a:rPr>
-              <a:t>Talk it through — 1 minute</a:t>
+              <a:t>Talk it through — 2 minutes</a:t>
             </a:r>
             <a:endParaRPr lang="en-US" sz="2600" dirty="0"/>
           </a:p>
@@ -2348,7 +2348,7 @@
                 <a:ea typeface="Arial" pitchFamily="34" charset="-122"/>
                 <a:cs typeface="Arial" pitchFamily="34" charset="-120"/>
               </a:rPr>
-              <a:t>Editor: read both notes out loud.</a:t>
+              <a:t>Speaker 1 is the partner whose first name comes first in the alphabet.</a:t>
             </a:r>
             <a:endParaRPr lang="en-US" sz="1800" dirty="0"/>
           </a:p>
@@ -2369,7 +2369,7 @@
                 <a:ea typeface="Arial" pitchFamily="34" charset="-122"/>
                 <a:cs typeface="Arial" pitchFamily="34" charset="-120"/>
               </a:rPr>
-              <a:t>Writer: ask ONE question — "Which sentence?" or "What would fit?"</a:t>
+              <a:t>Speaker 1 is the editor for the first minute: read your two notes out loud.</a:t>
             </a:r>
             <a:endParaRPr lang="en-US" sz="1800" dirty="0"/>
           </a:p>
@@ -2390,7 +2390,7 @@
                 <a:ea typeface="Arial" pitchFamily="34" charset="-122"/>
                 <a:cs typeface="Arial" pitchFamily="34" charset="-120"/>
               </a:rPr>
-              <a:t>Editor: answer using only the taste file.</a:t>
+              <a:t>Writer: ask ONE question.</a:t>
             </a:r>
             <a:endParaRPr lang="en-US" sz="1800" dirty="0"/>
           </a:p>
@@ -2411,7 +2411,28 @@
                 <a:ea typeface="Arial" pitchFamily="34" charset="-122"/>
                 <a:cs typeface="Arial" pitchFamily="34" charset="-120"/>
               </a:rPr>
-              <a:t>Then swap back.</a:t>
+              <a:t>Then switch — Speaker 2 runs the same minute.</a:t>
+            </a:r>
+            <a:endParaRPr lang="en-US" sz="1800" dirty="0"/>
+          </a:p>
+          <a:p>
+            <a:pPr marL="342900" indent="-342900">
+              <a:spcAft>
+                <a:spcPts val="800"/>
+              </a:spcAft>
+              <a:buSzPct val="100000"/>
+              <a:buChar char="■"/>
+            </a:pPr>
+            <a:r>
+              <a:rPr lang="en-US" sz="1800" dirty="0">
+                <a:solidFill>
+                  <a:srgbClr val="E8E8F5"/>
+                </a:solidFill>
+                <a:latin typeface="Arial" pitchFamily="34" charset="0"/>
+                <a:ea typeface="Arial" pitchFamily="34" charset="-122"/>
+                <a:cs typeface="Arial" pitchFamily="34" charset="-120"/>
+              </a:rPr>
+              <a:t>Then swap sheets back.</a:t>
             </a:r>
             <a:endParaRPr lang="en-US" sz="1800" dirty="0"/>
           </a:p>
@@ -2842,7 +2863,7 @@
                 <a:ea typeface="Arial" pitchFamily="34" charset="-122"/>
                 <a:cs typeface="Arial" pitchFamily="34" charset="-120"/>
               </a:rPr>
-              <a:t>4 MIN</a:t>
+              <a:t>5 MIN</a:t>
             </a:r>
             <a:endParaRPr lang="en-US" sz="1000" dirty="0"/>
           </a:p>
@@ -2924,7 +2945,7 @@
                 <a:ea typeface="Arial" pitchFamily="34" charset="-122"/>
                 <a:cs typeface="Arial" pitchFamily="34" charset="-120"/>
               </a:rPr>
-              <a:t>One change I made: the old words → the new words.</a:t>
+              <a:t>The one word or phrase you changed: old → new.</a:t>
             </a:r>
             <a:endParaRPr lang="en-US" sz="1800" dirty="0"/>
           </a:p>
@@ -3179,7 +3200,7 @@
                 <a:ea typeface="Arial" pitchFamily="34" charset="-122"/>
                 <a:cs typeface="Arial" pitchFamily="34" charset="-120"/>
               </a:rPr>
-              <a:t>Every AI job runs human → AI → human: you draft, the AI gives the notes, you revise. Write your taste down precisely and every editor — app, AI, or human — finally serves YOU.</a:t>
+              <a:t>A good AI job runs human → AI → human: you draft, the AI gives the notes, you revise. Write your taste down precisely and every editor — app, AI, or human — finally serves YOU.</a:t>
             </a:r>
             <a:endParaRPr lang="en-US" sz="1600" dirty="0"/>
           </a:p>
@@ -3858,7 +3879,7 @@
                 <a:ea typeface="Arial" pitchFamily="34" charset="-122"/>
                 <a:cs typeface="Arial" pitchFamily="34" charset="-120"/>
               </a:rPr>
-              <a:t>Unless you tell it — or it has saved notes about you — an AI doesn't know your taste. So how does it learn?</a:t>
+              <a:t>An AI doesn't know your taste unless you tell it, or it has saved notes about you. So how does it learn?</a:t>
             </a:r>
             <a:endParaRPr lang="en-US" sz="3000" dirty="0"/>
           </a:p>
@@ -4034,7 +4055,7 @@
                 <a:ea typeface="Arial" pitchFamily="34" charset="-122"/>
                 <a:cs typeface="Arial" pitchFamily="34" charset="-120"/>
               </a:rPr>
-              <a:t>8 MIN</a:t>
+              <a:t>6 MIN</a:t>
             </a:r>
             <a:endParaRPr lang="en-US" sz="1000" dirty="0"/>
           </a:p>
@@ -4744,11 +4765,11 @@
         <p:spPr>
           <a:xfrm>
             <a:off x="502920" y="1188720"/>
-            <a:ext cx="3931920" cy="3406140"/>
+            <a:ext cx="2560320" cy="3406140"/>
           </a:xfrm>
           <a:prstGeom prst="roundRect">
             <a:avLst>
-              <a:gd name="adj" fmla="val 3758"/>
+              <a:gd name="adj" fmla="val 5000"/>
             </a:avLst>
           </a:prstGeom>
           <a:solidFill>
@@ -4770,8 +4791,47 @@
         </p:nvSpPr>
         <p:spPr>
           <a:xfrm>
-            <a:off x="731520" y="1371600"/>
-            <a:ext cx="3474720" cy="365760"/>
+            <a:off x="731520" y="2057400"/>
+            <a:ext cx="2103120" cy="457200"/>
+          </a:xfrm>
+          <a:prstGeom prst="rect">
+            <a:avLst/>
+          </a:prstGeom>
+          <a:noFill/>
+          <a:ln/>
+        </p:spPr>
+        <p:txBody>
+          <a:bodyPr wrap="square" lIns="0" tIns="0" rIns="0" bIns="0" rtlCol="0" anchor="ctr"/>
+          <a:lstStyle/>
+          <a:p>
+            <a:pPr indent="0" marL="0">
+              <a:buNone/>
+            </a:pPr>
+            <a:r>
+              <a:rPr lang="en-US" sz="1400" b="1" dirty="0">
+                <a:solidFill>
+                  <a:srgbClr val="FFB020"/>
+                </a:solidFill>
+                <a:latin typeface="Arial" pitchFamily="34" charset="0"/>
+                <a:ea typeface="Arial" pitchFamily="34" charset="-122"/>
+                <a:cs typeface="Arial" pitchFamily="34" charset="-120"/>
+              </a:rPr>
+              <a:t>The draft (look at 2)</a:t>
+            </a:r>
+            <a:endParaRPr lang="en-US" sz="1400" dirty="0"/>
+          </a:p>
+        </p:txBody>
+      </p:sp>
+      <p:sp>
+        <p:nvSpPr>
+          <p:cNvPr id="8" name="Text 5"/>
+          <p:cNvSpPr txBox="1"/>
+          <p:nvPr/>
+        </p:nvSpPr>
+        <p:spPr>
+          <a:xfrm>
+            <a:off x="731520" y="2560320"/>
+            <a:ext cx="2103120" cy="1805940"/>
           </a:xfrm>
           <a:prstGeom prst="rect">
             <a:avLst/>
@@ -4787,56 +4847,51 @@
               <a:buNone/>
             </a:pPr>
             <a:r>
-              <a:rPr lang="en-US" sz="1300" b="1" spc="100" kern="0" dirty="0">
-                <a:solidFill>
-                  <a:srgbClr val="A9A9C4"/>
-                </a:solidFill>
-                <a:latin typeface="Arial" pitchFamily="34" charset="0"/>
-                <a:ea typeface="Arial" pitchFamily="34" charset="-122"/>
-                <a:cs typeface="Arial" pitchFamily="34" charset="-120"/>
-              </a:rPr>
-              <a:t>GENERIC NOTE</a:t>
-            </a:r>
-            <a:endParaRPr lang="en-US" sz="1300" dirty="0"/>
-          </a:p>
-        </p:txBody>
-      </p:sp>
-      <p:sp>
-        <p:nvSpPr>
-          <p:cNvPr id="8" name="Text 5"/>
-          <p:cNvSpPr txBox="1"/>
-          <p:nvPr/>
-        </p:nvSpPr>
-        <p:spPr>
-          <a:xfrm>
-            <a:off x="731520" y="1828800"/>
-            <a:ext cx="3474720" cy="2583180"/>
-          </a:xfrm>
-          <a:prstGeom prst="rect">
-            <a:avLst/>
-          </a:prstGeom>
-          <a:noFill/>
-          <a:ln/>
-        </p:spPr>
-        <p:txBody>
-          <a:bodyPr wrap="square" lIns="0" tIns="0" rIns="0" bIns="0" rtlCol="0" anchor="t"/>
-          <a:lstStyle/>
+              <a:rPr lang="en-US" sz="1400" dirty="0">
+                <a:solidFill>
+                  <a:srgbClr val="E8E8F5"/>
+                </a:solidFill>
+                <a:latin typeface="Arial" pitchFamily="34" charset="0"/>
+                <a:ea typeface="Arial" pitchFamily="34" charset="-122"/>
+                <a:cs typeface="Arial" pitchFamily="34" charset="-120"/>
+              </a:rPr>
+              <a:t>1. "Hello and welcome to my channel!"</a:t>
+            </a:r>
+            <a:endParaRPr lang="en-US" sz="1400" dirty="0"/>
+          </a:p>
           <a:p>
             <a:pPr indent="0" marL="0">
               <a:buNone/>
             </a:pPr>
             <a:r>
-              <a:rPr lang="en-US" sz="1700" dirty="0">
-                <a:solidFill>
-                  <a:srgbClr val="FFFFFF"/>
-                </a:solidFill>
-                <a:latin typeface="Arial" pitchFamily="34" charset="0"/>
-                <a:ea typeface="Arial" pitchFamily="34" charset="-122"/>
-                <a:cs typeface="Arial" pitchFamily="34" charset="-120"/>
-              </a:rPr>
-              <a:t>"Make it more interesting."</a:t>
-            </a:r>
-            <a:endParaRPr lang="en-US" sz="1700" dirty="0"/>
+              <a:rPr lang="en-US" sz="1400" dirty="0">
+                <a:solidFill>
+                  <a:srgbClr val="E8E8F5"/>
+                </a:solidFill>
+                <a:latin typeface="Arial" pitchFamily="34" charset="0"/>
+                <a:ea typeface="Arial" pitchFamily="34" charset="-122"/>
+                <a:cs typeface="Arial" pitchFamily="34" charset="-120"/>
+              </a:rPr>
+              <a:t>2. "I enjoy various hobbies such as gaming and cooking."</a:t>
+            </a:r>
+            <a:endParaRPr lang="en-US" sz="1400" dirty="0"/>
+          </a:p>
+          <a:p>
+            <a:pPr indent="0" marL="0">
+              <a:buNone/>
+            </a:pPr>
+            <a:r>
+              <a:rPr lang="en-US" sz="1400" dirty="0">
+                <a:solidFill>
+                  <a:srgbClr val="E8E8F5"/>
+                </a:solidFill>
+                <a:latin typeface="Arial" pitchFamily="34" charset="0"/>
+                <a:ea typeface="Arial" pitchFamily="34" charset="-122"/>
+                <a:cs typeface="Arial" pitchFamily="34" charset="-120"/>
+              </a:rPr>
+              <a:t>3. "I upload content on a regular basis."</a:t>
+            </a:r>
+            <a:endParaRPr lang="en-US" sz="1400" dirty="0"/>
           </a:p>
         </p:txBody>
       </p:sp>
@@ -4848,20 +4903,20 @@
         </p:nvSpPr>
         <p:spPr>
           <a:xfrm>
-            <a:off x="4709160" y="1188720"/>
-            <a:ext cx="3931920" cy="3406140"/>
+            <a:off x="3291840" y="1188720"/>
+            <a:ext cx="2560320" cy="3406140"/>
           </a:xfrm>
           <a:prstGeom prst="roundRect">
             <a:avLst>
-              <a:gd name="adj" fmla="val 3758"/>
+              <a:gd name="adj" fmla="val 5000"/>
             </a:avLst>
           </a:prstGeom>
           <a:solidFill>
-            <a:srgbClr val="2F2A5C"/>
+            <a:srgbClr val="262648"/>
           </a:solidFill>
-          <a:ln w="19050">
+          <a:ln w="12700">
             <a:solidFill>
-              <a:srgbClr val="FFB020"/>
+              <a:srgbClr val="262648"/>
             </a:solidFill>
             <a:prstDash val="solid"/>
           </a:ln>
@@ -4875,8 +4930,47 @@
         </p:nvSpPr>
         <p:spPr>
           <a:xfrm>
-            <a:off x="4937760" y="1371600"/>
-            <a:ext cx="3474720" cy="365760"/>
+            <a:off x="3520440" y="2057400"/>
+            <a:ext cx="2103120" cy="457200"/>
+          </a:xfrm>
+          <a:prstGeom prst="rect">
+            <a:avLst/>
+          </a:prstGeom>
+          <a:noFill/>
+          <a:ln/>
+        </p:spPr>
+        <p:txBody>
+          <a:bodyPr wrap="square" lIns="0" tIns="0" rIns="0" bIns="0" rtlCol="0" anchor="ctr"/>
+          <a:lstStyle/>
+          <a:p>
+            <a:pPr indent="0" marL="0">
+              <a:buNone/>
+            </a:pPr>
+            <a:r>
+              <a:rPr lang="en-US" sz="1700" b="1" dirty="0">
+                <a:solidFill>
+                  <a:srgbClr val="FFB020"/>
+                </a:solidFill>
+                <a:latin typeface="Arial" pitchFamily="34" charset="0"/>
+                <a:ea typeface="Arial" pitchFamily="34" charset="-122"/>
+                <a:cs typeface="Arial" pitchFamily="34" charset="-120"/>
+              </a:rPr>
+              <a:t>Generic note</a:t>
+            </a:r>
+            <a:endParaRPr lang="en-US" sz="1700" dirty="0"/>
+          </a:p>
+        </p:txBody>
+      </p:sp>
+      <p:sp>
+        <p:nvSpPr>
+          <p:cNvPr id="11" name="Text 8"/>
+          <p:cNvSpPr txBox="1"/>
+          <p:nvPr/>
+        </p:nvSpPr>
+        <p:spPr>
+          <a:xfrm>
+            <a:off x="3520440" y="2560320"/>
+            <a:ext cx="2103120" cy="1805940"/>
           </a:xfrm>
           <a:prstGeom prst="rect">
             <a:avLst/>
@@ -4892,7 +4986,73 @@
               <a:buNone/>
             </a:pPr>
             <a:r>
-              <a:rPr lang="en-US" sz="1300" b="1" spc="100" kern="0" dirty="0">
+              <a:rPr lang="en-US" sz="1400" dirty="0">
+                <a:solidFill>
+                  <a:srgbClr val="E8E8F5"/>
+                </a:solidFill>
+                <a:latin typeface="Arial" pitchFamily="34" charset="0"/>
+                <a:ea typeface="Arial" pitchFamily="34" charset="-122"/>
+                <a:cs typeface="Arial" pitchFamily="34" charset="-120"/>
+              </a:rPr>
+              <a:t>"Make it more interesting."</a:t>
+            </a:r>
+            <a:endParaRPr lang="en-US" sz="1400" dirty="0"/>
+          </a:p>
+        </p:txBody>
+      </p:sp>
+      <p:sp>
+        <p:nvSpPr>
+          <p:cNvPr id="12" name="Shape 9"/>
+          <p:cNvSpPr/>
+          <p:nvPr/>
+        </p:nvSpPr>
+        <p:spPr>
+          <a:xfrm>
+            <a:off x="6080760" y="1188720"/>
+            <a:ext cx="2560320" cy="3406140"/>
+          </a:xfrm>
+          <a:prstGeom prst="roundRect">
+            <a:avLst>
+              <a:gd name="adj" fmla="val 5000"/>
+            </a:avLst>
+          </a:prstGeom>
+          <a:solidFill>
+            <a:srgbClr val="262648"/>
+          </a:solidFill>
+          <a:ln w="12700">
+            <a:solidFill>
+              <a:srgbClr val="262648"/>
+            </a:solidFill>
+            <a:prstDash val="solid"/>
+          </a:ln>
+        </p:spPr>
+      </p:sp>
+      <p:sp>
+        <p:nvSpPr>
+          <p:cNvPr id="13" name="Text 10"/>
+          <p:cNvSpPr txBox="1"/>
+          <p:nvPr/>
+        </p:nvSpPr>
+        <p:spPr>
+          <a:xfrm>
+            <a:off x="6309360" y="2057400"/>
+            <a:ext cx="2103120" cy="457200"/>
+          </a:xfrm>
+          <a:prstGeom prst="rect">
+            <a:avLst/>
+          </a:prstGeom>
+          <a:noFill/>
+          <a:ln/>
+        </p:spPr>
+        <p:txBody>
+          <a:bodyPr wrap="square" lIns="0" tIns="0" rIns="0" bIns="0" rtlCol="0" anchor="ctr"/>
+          <a:lstStyle/>
+          <a:p>
+            <a:pPr indent="0" marL="0">
+              <a:buNone/>
+            </a:pPr>
+            <a:r>
+              <a:rPr lang="en-US" sz="1700" b="1" dirty="0">
                 <a:solidFill>
                   <a:srgbClr val="FFB020"/>
                 </a:solidFill>
@@ -4900,22 +5060,22 @@
                 <a:ea typeface="Arial" pitchFamily="34" charset="-122"/>
                 <a:cs typeface="Arial" pitchFamily="34" charset="-120"/>
               </a:rPr>
-              <a:t>TASTE-FILE NOTE</a:t>
-            </a:r>
-            <a:endParaRPr lang="en-US" sz="1300" dirty="0"/>
-          </a:p>
-        </p:txBody>
-      </p:sp>
-      <p:sp>
-        <p:nvSpPr>
-          <p:cNvPr id="11" name="Text 8"/>
-          <p:cNvSpPr txBox="1"/>
-          <p:nvPr/>
-        </p:nvSpPr>
-        <p:spPr>
-          <a:xfrm>
-            <a:off x="4937760" y="1828800"/>
-            <a:ext cx="3474720" cy="2583180"/>
+              <a:t>Taste-file note</a:t>
+            </a:r>
+            <a:endParaRPr lang="en-US" sz="1700" dirty="0"/>
+          </a:p>
+        </p:txBody>
+      </p:sp>
+      <p:sp>
+        <p:nvSpPr>
+          <p:cNvPr id="14" name="Text 11"/>
+          <p:cNvSpPr txBox="1"/>
+          <p:nvPr/>
+        </p:nvSpPr>
+        <p:spPr>
+          <a:xfrm>
+            <a:off x="6309360" y="2560320"/>
+            <a:ext cx="2103120" cy="1805940"/>
           </a:xfrm>
           <a:prstGeom prst="rect">
             <a:avLst/>
@@ -4931,9 +5091,9 @@
               <a:buNone/>
             </a:pPr>
             <a:r>
-              <a:rPr lang="en-US" sz="1700" dirty="0">
-                <a:solidFill>
-                  <a:srgbClr val="FFFFFF"/>
+              <a:rPr lang="en-US" sz="1400" dirty="0">
+                <a:solidFill>
+                  <a:srgbClr val="E8E8F5"/>
                 </a:solidFill>
                 <a:latin typeface="Arial" pitchFamily="34" charset="0"/>
                 <a:ea typeface="Arial" pitchFamily="34" charset="-122"/>
@@ -4941,7 +5101,7 @@
               </a:rPr>
               <a:t>"Your taste file says funny and blunt — sentence 2 sounds like a homework robot. Say it like you'd text it."</a:t>
             </a:r>
-            <a:endParaRPr lang="en-US" sz="1700" dirty="0"/>
+            <a:endParaRPr lang="en-US" sz="1400" dirty="0"/>
           </a:p>
         </p:txBody>
       </p:sp>
@@ -5342,7 +5502,7 @@
                 <a:ea typeface="Arial" pitchFamily="34" charset="-122"/>
                 <a:cs typeface="Arial" pitchFamily="34" charset="-120"/>
               </a:rPr>
-              <a:t>12 MIN</a:t>
+              <a:t>10 MIN</a:t>
             </a:r>
             <a:endParaRPr lang="en-US" sz="1000" dirty="0"/>
           </a:p>
@@ -5445,7 +5605,7 @@
                 <a:ea typeface="Arial" pitchFamily="34" charset="-122"/>
                 <a:cs typeface="Arial" pitchFamily="34" charset="-120"/>
               </a:rPr>
-              <a:t>Section 2 — How I Like It Served: check every format you actually enjoy reading.</a:t>
+              <a:t>Section 2 — How I Like It: check every format you actually enjoy reading.</a:t>
             </a:r>
             <a:endParaRPr lang="en-US" sz="1800" dirty="0"/>
           </a:p>
@@ -5466,7 +5626,7 @@
                 <a:ea typeface="Arial" pitchFamily="34" charset="-122"/>
                 <a:cs typeface="Arial" pitchFamily="34" charset="-120"/>
               </a:rPr>
-              <a:t>Section 3 — Pet Peeves: "Editor, never do this to my writing..." Write two.</a:t>
+              <a:t>Section 3 — Pet Peeves: "Editor, never ______." Write two.</a:t>
             </a:r>
             <a:endParaRPr lang="en-US" sz="1800" dirty="0"/>
           </a:p>
@@ -5684,7 +5844,7 @@
                 <a:ea typeface="Arial" pitchFamily="34" charset="-122"/>
                 <a:cs typeface="Arial" pitchFamily="34" charset="-120"/>
               </a:rPr>
-              <a:t>15 MIN</a:t>
+              <a:t>18 MIN</a:t>
             </a:r>
             <a:endParaRPr lang="en-US" sz="1000" dirty="0"/>
           </a:p>
@@ -5968,7 +6128,7 @@
                 <a:ea typeface="Arial" pitchFamily="34" charset="-122"/>
                 <a:cs typeface="Arial" pitchFamily="34" charset="-120"/>
               </a:rPr>
-              <a:t>Editor's notes   ·   5 min</a:t>
+              <a:t>Editor's notes   ·   7 min</a:t>
             </a:r>
             <a:endParaRPr lang="en-US" sz="1500" dirty="0"/>
           </a:p>
@@ -6007,7 +6167,7 @@
                 <a:ea typeface="Arial" pitchFamily="34" charset="-122"/>
                 <a:cs typeface="Arial" pitchFamily="34" charset="-120"/>
               </a:rPr>
-              <a:t>Swap ALL pages. Read THEIR taste file, then write 2 notes on THEIR page 2 — each names a section. No rewriting. Then talk for 1 minute.</a:t>
+              <a:t>Swap ALL pages. Read THEIR taste file, then write 2 notes on THEIR page 2 — each names a section. No rewriting. Then talk for 2 minutes.</a:t>
             </a:r>
             <a:endParaRPr lang="en-US" sz="1300" dirty="0"/>
           </a:p>
@@ -6110,7 +6270,7 @@
                 <a:ea typeface="Arial" pitchFamily="34" charset="-122"/>
                 <a:cs typeface="Arial" pitchFamily="34" charset="-120"/>
               </a:rPr>
-              <a:t>Revise it yourself   ·   5 min</a:t>
+              <a:t>Revise it yourself   ·   6 min</a:t>
             </a:r>
             <a:endParaRPr lang="en-US" sz="1500" dirty="0"/>
           </a:p>
@@ -6149,7 +6309,7 @@
                 <a:ea typeface="Arial" pitchFamily="34" charset="-122"/>
                 <a:cs typeface="Arial" pitchFamily="34" charset="-120"/>
               </a:rPr>
-              <a:t>Swap back. Rewrite your own draft on page 3. Star (*) every change. Your editor does not write a single word for you.</a:t>
+              <a:t>Swap back. Rewrite only the sentences your notes point at, plus enough around them to make it read. Star (*) every change.</a:t>
             </a:r>
             <a:endParaRPr lang="en-US" sz="1300" dirty="0"/>
           </a:p>

</xml_diff>

<commit_message>
L4 rewritten on Opus 5.5 and kept after a 19-0 blind A/B: a cover that pictures an editor's note instead of ghostwriting, a worked example that obeys the lesson's own two-notes rule, and a title that names peer editing. Card headings now share one size across a slide in every deck
Co-Authored-By: Claude Opus 5.5 <noreply@anthropic.com>
Claude-Session: https://claude.ai/code/session_01VWaJFc84eoA3U4f2VjTKjw
</commit_message>
<xml_diff>
--- a/products/ai-taste-file/dist/Teach AI Your Taste - Slides.pptx
+++ b/products/ai-taste-file/dist/Teach AI Your Taste - Slides.pptx
@@ -514,7 +514,7 @@
           <a:p>
             <a:r>
               <a:rPr lang="en-US" dirty="0"/>
-              <a:t>Open on this slide while students settle. Worksheet: My Taste File + The Editor's Chair, 3 pages, one per student. Deck follows the lesson plan block for block; minute chips top-right match it.</a:t>
+              <a:t>Open on this slide while students settle. Worksheet: My Taste File, The Editor's Chair, and Revise &amp; Last Check, 3 pages, one per student. The deck follows the lesson plan block for block; the minute chips top-right match it.</a:t>
             </a:r>
             <a:endParaRPr lang="en-US" dirty="0"/>
           </a:p>
@@ -602,7 +602,7 @@
           <a:p>
             <a:r>
               <a:rPr lang="en-US" dirty="0"/>
-              <a:t>This is the SL.6.1 moment, and the turn order is what makes it one: every student reads notes aloud AND asks a question. Same text is printed on worksheet page 2, with the two question frames — "Which sentence?" or "What would fit?" Sample 3–4 pairs: listen for the answer to cite a section ("Section 3 says no textbook words"), not the editor's own taste ("I'd just make it funnier"). WHAT IF a pair can't tell who is Speaker 1: "Whose name starts closer to A?" WHAT IF the writer argues back: "Ask which sentence, not whether." Both check checklist row 4 on page 3 afterwards.</a:t>
+              <a:t>This is the SL.6.1 moment, and the turn order is what makes it one: every student reads notes aloud AND asks a question. The same text is printed on worksheet page 2, with the two question frames: "Which sentence?" or "What would fit?" Sample 3–4 pairs. Listen for an answer that cites a section ("Section 3 says no textbook voice"), not the editor's own taste ("I'd just make it funnier"). WHAT IF two partners have the same first letter: "Check the second letter." Same name? "Whoever sits nearer the door goes first." WHAT IF the writer argues back: "Ask which sentence, not whether." Both check checklist row 4 on page 3 afterwards.</a:t>
             </a:r>
             <a:endParaRPr lang="en-US" dirty="0"/>
           </a:p>
@@ -690,7 +690,7 @@
           <a:p>
             <a:r>
               <a:rPr lang="en-US" dirty="0"/>
-              <a:t>Page 3, after the revision. Students check all four before the Last Check. Rows 1 and 3 verify the human at both ends (own draft, own revision — check against the handwriting and the stars); row 4 verifies the talk you sampled. WHAT IF a student changed nothing: "Your editor pointed at section 3. Read that section out loud. Now change one sentence to match it." TRANSITION: "Checklist — four checks. Then the Last Check at the bottom: three answers, your own words, five minutes."</a:t>
+              <a:t>Page 3, after the revision. Students check all four before the Last Check. Rows 1 and 3 check the human at both ends (own draft, own revision; check against the handwriting and the stars). Row 4 checks the talk you sampled. WHAT IF a student changed nothing: "Your editor pointed at Section 3. Read it out loud. Now change one sentence to match it." TRANSITION: "Four checks. Then the Last Check: three answers, your own words, five minutes. Short is fine on #1."</a:t>
             </a:r>
             <a:endParaRPr lang="en-US" dirty="0"/>
           </a:p>
@@ -778,7 +778,7 @@
           <a:p>
             <a:r>
               <a:rPr lang="en-US" dirty="0"/>
-              <a:t>Solo, 5 minutes. Collect. KEY — #1: names one word or phrase and gives it both ways, old → new ("I made it funnier" without the words = redo). #2: names a section and the match: "Section 1 says blunt; the new line is blunt." #3 (Objective 1): proficient = "make it better" names no sentence and no direction — better for whom? — while the real note named a section and a sentence. Jaylen exemplar: "'I enjoy various hobbies' → 'I lose at games and cook worse.' Section 3 says no textbook words. 'Make it better' doesn't say what's wrong or what better means for ME." WHAT IF "I made it better": "Which word changed? Write the old word and the new one."</a:t>
+              <a:t>Solo, 5 minutes. Collect. KEY — #1: names one word or phrase and gives it both ways, old → new ("I made it funnier" without the words = redo). #2: names a section and the match: "Section 1 says blunt; the new line is blunt." #3 (Objective 1): proficient = "make it better" names no sentence and no direction (better for whom?), while the real note named a section and a sentence. Jaylen exemplar: #1 "'I enjoy various hobbies such as gaming and cooking' → 'I lose at games and cook worse.'" #2 "Section 3 says no textbook voice; Section 1 says funny and blunt." #3 "'Make it better' doesn't say what's wrong or what better means for ME. The note that named Section 3 told me which sentence and why." WHAT IF "I made it better": "Which word changed? Write the old word and the new one."</a:t>
             </a:r>
             <a:endParaRPr lang="en-US" dirty="0"/>
           </a:p>
@@ -866,7 +866,7 @@
           <a:p>
             <a:r>
               <a:rPr lang="en-US" dirty="0"/>
-              <a:t>Close on this. Next in the unit: Robots Do the Boring Work (Lesson 5 — in the unit bundle, or sold separately). This lesson stands alone either way.</a:t>
+              <a:t>Close on this. Next in the unit: Robots Do the Boring Work (Lesson 5, sold separately). This lesson stands alone either way.</a:t>
             </a:r>
             <a:endParaRPr lang="en-US" dirty="0"/>
           </a:p>
@@ -954,7 +954,7 @@
           <a:p>
             <a:r>
               <a:rPr lang="en-US" dirty="0"/>
-              <a:t>Take 2–3 answers. Land on: every like, skip, rewatch, and follow is a signal. You taught it your taste — and the more precisely you signal, the better the feed serves you. Your feed is your taste, written down in likes and skips. WHAT IF a student says 'my feed is random': 'Random is a signal too — what do you skip in the first second? That's a like in reverse.' Nobody raises a hand? Name your own feed first.</a:t>
+              <a:t>Any feed counts: YouTube, a music app, even a game store's "recommended" row. Take 2–3 answers. Land on: every like, skip, rewatch, and follow is a signal. Nobody guessed. You taught it. Your feed is your taste, written down in likes and skips. WHAT IF a student says 'my feed is random': "Random is a signal too. What do you skip in the first second? That's a like in reverse." Nobody raises a hand? Name your own feed first.</a:t>
             </a:r>
             <a:endParaRPr lang="en-US" dirty="0"/>
           </a:p>
@@ -1042,7 +1042,7 @@
           <a:p>
             <a:r>
               <a:rPr lang="en-US" dirty="0"/>
-              <a:t>ANSWER (say it, don't show it): the same way the feed did — you teach it. Bridge, verbatim: "Here's the other side. An AI doesn't know your taste unless you tell it, or it has saved notes about you. Today you write your taste down on one page, and then you use it to make YOUR OWN writing better." TRANSITION: "So what happens when the editor knows nothing about you? Watch."</a:t>
+              <a:t>ANSWER (say it, don't show it): your taste, written down. You teach it, the same way you taught the feed. Bridge, verbatim: "Here's the other side. An AI doesn't know your taste unless you tell it, or it has saved notes about you. Today you write yours down on one page, then use it to make YOUR OWN writing better." TRANSITION: "So what happens when your editor knows nothing about you? Let's see."</a:t>
             </a:r>
             <a:endParaRPr lang="en-US" dirty="0"/>
           </a:p>
@@ -1130,7 +1130,7 @@
           <a:p>
             <a:r>
               <a:rPr lang="en-US" dirty="0"/>
-              <a:t>Three beats, in order. Beat 2, if your class did the genie lesson: the taste file is your Requirements, written once so you never retype them. Beat 3 — say it plainly: "AI is your editor, not your ghostwriter." Then advance to watch one get fixed.</a:t>
+              <a:t>Three beats, in order. Beat 2, if your class did Lesson 1, How to Talk to AI: the taste file is the R in P.R.O., written down once. Beat 3: say it plainly, once. "AI is your editor, not your ghostwriter." Then advance: which note could you use?</a:t>
             </a:r>
             <a:endParaRPr lang="en-US" dirty="0"/>
           </a:p>
@@ -1218,7 +1218,7 @@
           <a:p>
             <a:r>
               <a:rPr lang="en-US" dirty="0"/>
-              <a:t>Read the draft aloud first, then both notes. Ask: which note could you actually act on? The generic note fits any writer. The taste-file note names sentence 2 and points at the writer's own file — that's the whole difference. WHAT IF 'the AI I use already knows me': 'Some tools do save notes about you. A fresh chat usually doesn't — and either way, a taste file is the fastest way to make sure the notes fit.'</a:t>
+              <a:t>Read the draft aloud first, then both notes. Ask: which one could you actually act on? The generic note fits any writer. The taste-file note names a section AND a sentence. That's the whole difference. WHAT IF 'the AI I use already knows me': "Some tools save notes about you. A fresh chat usually doesn't. Either way, the file makes sure the notes fit."</a:t>
             </a:r>
             <a:endParaRPr lang="en-US" dirty="0"/>
           </a:p>
@@ -1306,7 +1306,7 @@
           <a:p>
             <a:r>
               <a:rPr lang="en-US" dirty="0"/>
-              <a:t>Say it plainly: a ghostwriter writes it for you and lets you put your name on it. Today, nobody in this room is a ghostwriter — not a partner, not an AI. Then move on. TRANSITION: "Page 1. Your taste, written down — five sections, ten minutes, solo. Nobody swaps anything yet."</a:t>
+              <a:t>Say it once: a ghostwriter writes it for you and lets you put your name on it. Today nobody in this room is a ghostwriter, not a partner and not an AI. Then move on. TRANSITION: "Page 1. Your taste, written down — five sections, ten minutes, solo. Nobody swaps yet."</a:t>
             </a:r>
             <a:endParaRPr lang="en-US" dirty="0"/>
           </a:p>
@@ -1394,7 +1394,7 @@
           <a:p>
             <a:r>
               <a:rPr lang="en-US" dirty="0"/>
-              <a:t>Solo on worksheet page 1. Circulate and push for specifics: "quiet" beats "good"; "don't make me sound like a textbook" beats "be nice." WHAT IF stuck on So Me: "Read me the last text you sent a friend. That's your voice." Minute 8: two volunteers read a So Me sentence — the class hears how different real taste sounds. TRANSITION: "Flip to page 2. Three to four sentences: the About Me for a channel or profile you'd really make. Match your taste file. Solo — five minutes."</a:t>
+              <a:t>Solo on worksheet page 1. Circulate and push for specifics: "quiet" beats "good"; "don't make me sound like a textbook" beats "be nice." WHAT IF stuck on So Me: "Read me the last text you sent a friend. That's your voice." Still stuck? Read Jaylen's pair aloud: "Saturday I made the world's saddest pancake and ate it anyway." / "On Saturday I prepared a breakfast item that did not meet expectations." Minute 8: two volunteers read a So Me sentence, so the class hears how different real taste sounds. TRANSITION: "Flip to page 2. Three to four sentences: the About Me for a channel or profile you'd really make. Match your taste file. Solo — five minutes."</a:t>
             </a:r>
             <a:endParaRPr lang="en-US" dirty="0"/>
           </a:p>
@@ -1482,7 +1482,7 @@
           <a:p>
             <a:r>
               <a:rPr lang="en-US" dirty="0"/>
-              <a:t>DRAFT — WHAT IF 'I don't have a channel': "The one you WOULD make — a game name, a team, a club, a pet's account." TRANSITION: "Pens down. Swap ALL your pages with your partner. You are now their editor — and page 1 is the only thing you're allowed to know about them." NOTES (4 min writing): put the next slide up. WHAT IF the editor rewrites: "You're the editor. Hand the pen back." No section number: "Which section? No section, no note." With devices: run Step 2 once on YOUR projected account — one volunteer's taste file and draft in the copy-ready prompt (Teacher Guide) — and the class checks whether each note names a section. Students never need an account. TRANSITION after the 4 minutes of writing: "Speaker 1, you are the editor first — read your two notes out loud. Writers, one question." At the one-minute call: "Switch. Speaker 2 runs the same minute." Then: "Swap back. Page 3 — your draft, your pen. Star every change."</a:t>
+              <a:t>DRAFT — WHAT IF 'I don't have a channel': "The one you WOULD make — a game name, a team, a club, a pet's account." TRANSITION: "Pens down. Swap ALL your pages with your partner. You're their editor now — and page 1 is the only thing you're allowed to know about them." NOTES, by the clock: 0:00 swap (30 s) · 0:30 write 2 notes (4 min; put the next slide up) · 4:30 read the turn order aloud, Speaker 1's minute · 5:30 Speaker 2's minute · 6:30 swap back (30 s). WHAT IF the editor rewrites: "You're the editor. Hand the pen back." No section number: "Which section? No section, no note." Typing? Partners swap Chromebooks, not sheets; notes go in the Note 1 and Note 2 fields. With devices: run Step 2 once on YOUR projected account, with one volunteer's taste file and draft in the copy-ready prompt (Teacher Guide). The class checks that each note names a section. Students never need an account. TRANSITION at 4:30: "Pens down. Speaker 1, you're the editor first. Writers, one question." At 5:30: "Switch. Speaker 2, you're the editor now." At 6:30: "Swap back. Page 3 — your draft, your pen. Star every change." REVISE: read the Step 3 line aloud, word for word.</a:t>
             </a:r>
             <a:endParaRPr lang="en-US" dirty="0"/>
           </a:p>
@@ -1570,7 +1570,7 @@
           <a:p>
             <a:r>
               <a:rPr lang="en-US" dirty="0"/>
-              <a:t>Leave this up while editors write. Three rules: use only the taste file, exactly 2 notes, notes not rewrites. The second the editor writes a sentence, they've become a ghostwriter. Second exemplar pair for the board if needed — reject: "It's good. Maybe add more." accept: "Section 2 says short and punchy — sentence 3 is 22 words. Which half matters?"</a:t>
+              <a:t>Leave this up while editors write. Three rules: use only the taste file, exactly 2 notes, notes not rewrites. The second the editor writes a sentence, they've become a ghostwriter. A second pair for the board if needed. Reject: "It's good. Maybe add more." Accept: "Section 2 says short and punchy — sentence 3 is 22 words. Which half matters?"</a:t>
             </a:r>
             <a:endParaRPr lang="en-US" dirty="0"/>
           </a:p>
@@ -2117,7 +2117,7 @@
                 <a:ea typeface="Arial" pitchFamily="34" charset="-122"/>
                 <a:cs typeface="Arial" pitchFamily="34" charset="-120"/>
               </a:rPr>
-              <a:t>Teach AI Your Taste</a:t>
+              <a:t>Teach AI Your Taste</a:t>
             </a:r>
             <a:endParaRPr lang="en-US" sz="4000" dirty="0"/>
           </a:p>
@@ -2411,7 +2411,28 @@
                 <a:ea typeface="Arial" pitchFamily="34" charset="-122"/>
                 <a:cs typeface="Arial" pitchFamily="34" charset="-120"/>
               </a:rPr>
-              <a:t>Then switch — Speaker 2 runs the same minute.</a:t>
+              <a:t>Editor: answer from THEIR taste file — never your own taste.</a:t>
+            </a:r>
+            <a:endParaRPr lang="en-US" sz="1800" dirty="0"/>
+          </a:p>
+          <a:p>
+            <a:pPr marL="342900" indent="-342900">
+              <a:spcAft>
+                <a:spcPts val="800"/>
+              </a:spcAft>
+              <a:buSzPct val="100000"/>
+              <a:buChar char="■"/>
+            </a:pPr>
+            <a:r>
+              <a:rPr lang="en-US" sz="1800" dirty="0">
+                <a:solidFill>
+                  <a:srgbClr val="E8E8F5"/>
+                </a:solidFill>
+                <a:latin typeface="Arial" pitchFamily="34" charset="0"/>
+                <a:ea typeface="Arial" pitchFamily="34" charset="-122"/>
+                <a:cs typeface="Arial" pitchFamily="34" charset="-120"/>
+              </a:rPr>
+              <a:t>Then switch: Speaker 2 is the editor for minute two.</a:t>
             </a:r>
             <a:endParaRPr lang="en-US" sz="1800" dirty="0"/>
           </a:p>
@@ -2581,7 +2602,7 @@
                 <a:ea typeface="Arial" pitchFamily="34" charset="-122"/>
                 <a:cs typeface="Arial" pitchFamily="34" charset="-120"/>
               </a:rPr>
-              <a:t>Editor's Loop Checklist</a:t>
+              <a:t>Editor Loop Checklist</a:t>
             </a:r>
             <a:endParaRPr lang="en-US" sz="2600" dirty="0"/>
           </a:p>
@@ -2645,7 +2666,7 @@
                 <a:ea typeface="Arial" pitchFamily="34" charset="-122"/>
                 <a:cs typeface="Arial" pitchFamily="34" charset="-120"/>
               </a:rPr>
-              <a:t>Each note names a taste-file section and says what to change — not "make it better."</a:t>
+              <a:t>My editor's notes each named a section and said what to change, not "make it better."</a:t>
             </a:r>
             <a:endParaRPr lang="en-US" sz="1800" dirty="0"/>
           </a:p>
@@ -2666,7 +2687,7 @@
                 <a:ea typeface="Arial" pitchFamily="34" charset="-122"/>
                 <a:cs typeface="Arial" pitchFamily="34" charset="-120"/>
               </a:rPr>
-              <a:t>I rewrote it myself and starred every change.</a:t>
+              <a:t>I made the changes myself and starred every one.</a:t>
             </a:r>
             <a:endParaRPr lang="en-US" sz="1800" dirty="0"/>
           </a:p>
@@ -2687,7 +2708,7 @@
                 <a:ea typeface="Arial" pitchFamily="34" charset="-122"/>
                 <a:cs typeface="Arial" pitchFamily="34" charset="-120"/>
               </a:rPr>
-              <a:t>We talked it through: notes read aloud, one question, an answer from my taste file.</a:t>
+              <a:t>My editor read both notes aloud, I asked one question, and they answered from my taste file.</a:t>
             </a:r>
             <a:endParaRPr lang="en-US" sz="1800" dirty="0"/>
           </a:p>
@@ -2945,7 +2966,7 @@
                 <a:ea typeface="Arial" pitchFamily="34" charset="-122"/>
                 <a:cs typeface="Arial" pitchFamily="34" charset="-120"/>
               </a:rPr>
-              <a:t>The one word or phrase you changed: old → new.</a:t>
+              <a:t>The one word or phrase you changed (old → new):</a:t>
             </a:r>
             <a:endParaRPr lang="en-US" sz="1800" dirty="0"/>
           </a:p>
@@ -2966,7 +2987,7 @@
                 <a:ea typeface="Arial" pitchFamily="34" charset="-122"/>
                 <a:cs typeface="Arial" pitchFamily="34" charset="-120"/>
               </a:rPr>
-              <a:t>It fits my taste file because… (name the section).</a:t>
+              <a:t>The new version fits my taste file because (name the section):</a:t>
             </a:r>
             <a:endParaRPr lang="en-US" sz="1800" dirty="0"/>
           </a:p>
@@ -3200,7 +3221,7 @@
                 <a:ea typeface="Arial" pitchFamily="34" charset="-122"/>
                 <a:cs typeface="Arial" pitchFamily="34" charset="-120"/>
               </a:rPr>
-              <a:t>A good AI job runs human → AI → human: you draft, the AI gives the notes, you revise. Write your taste down precisely and every editor — app, AI, or human — finally serves YOU.</a:t>
+              <a:t>A good AI job runs human → AI → human: you draft, the AI gives the notes, you revise. Your feed needed a month of likes to learn you. Your editor needed one page.</a:t>
             </a:r>
             <a:endParaRPr lang="en-US" sz="1600" dirty="0"/>
           </a:p>
@@ -3879,7 +3900,7 @@
                 <a:ea typeface="Arial" pitchFamily="34" charset="-122"/>
                 <a:cs typeface="Arial" pitchFamily="34" charset="-120"/>
               </a:rPr>
-              <a:t>An AI doesn't know your taste unless you tell it, or it has saved notes about you. So how does it learn?</a:t>
+              <a:t>An AI doesn't know your taste unless you tell it, or it has saved notes about you. So what do you hand it?</a:t>
             </a:r>
             <a:endParaRPr lang="en-US" sz="3000" dirty="0"/>
           </a:p>
@@ -4263,7 +4284,7 @@
                 <a:ea typeface="Arial" pitchFamily="34" charset="-122"/>
                 <a:cs typeface="Arial" pitchFamily="34" charset="-120"/>
               </a:rPr>
-              <a:t>Ask "give me feedback on my paragraph" and you get notes for a generic writer: "add detail." True for anyone, useful to no one.</a:t>
+              <a:t>Ask "give me feedback on my paragraph" and you usually get notes for a generic writer: "add detail." True for anyone, useful to no one.</a:t>
             </a:r>
             <a:endParaRPr lang="en-US" sz="1400" dirty="0"/>
           </a:p>
@@ -4385,7 +4406,7 @@
               <a:buNone/>
             </a:pPr>
             <a:r>
-              <a:rPr lang="en-US" sz="1700" b="1" dirty="0">
+              <a:rPr lang="en-US" sz="1400" b="1" dirty="0">
                 <a:solidFill>
                   <a:srgbClr val="FFB020"/>
                 </a:solidFill>
@@ -4395,7 +4416,7 @@
               </a:rPr>
               <a:t>The Taste File</a:t>
             </a:r>
-            <a:endParaRPr lang="en-US" sz="1700" dirty="0"/>
+            <a:endParaRPr lang="en-US" sz="1400" dirty="0"/>
           </a:p>
         </p:txBody>
       </p:sp>
@@ -4554,7 +4575,7 @@
               <a:buNone/>
             </a:pPr>
             <a:r>
-              <a:rPr lang="en-US" sz="1700" b="1" dirty="0">
+              <a:rPr lang="en-US" sz="1400" b="1" dirty="0">
                 <a:solidFill>
                   <a:srgbClr val="FFB020"/>
                 </a:solidFill>
@@ -4564,7 +4585,7 @@
               </a:rPr>
               <a:t>The editor loop</a:t>
             </a:r>
-            <a:endParaRPr lang="en-US" sz="1700" dirty="0"/>
+            <a:endParaRPr lang="en-US" sz="1400" dirty="0"/>
           </a:p>
         </p:txBody>
       </p:sp>
@@ -4750,7 +4771,7 @@
                 <a:ea typeface="Arial" pitchFamily="34" charset="-122"/>
                 <a:cs typeface="Arial" pitchFamily="34" charset="-120"/>
               </a:rPr>
-              <a:t>Watch one get fixed</a:t>
+              <a:t>Which note could you use?</a:t>
             </a:r>
             <a:endParaRPr lang="en-US" sz="2600" dirty="0"/>
           </a:p>
@@ -4816,7 +4837,7 @@
                 <a:ea typeface="Arial" pitchFamily="34" charset="-122"/>
                 <a:cs typeface="Arial" pitchFamily="34" charset="-120"/>
               </a:rPr>
-              <a:t>The draft (look at 2)</a:t>
+              <a:t>Draft: watch sentence 2</a:t>
             </a:r>
             <a:endParaRPr lang="en-US" sz="1400" dirty="0"/>
           </a:p>
@@ -4947,7 +4968,7 @@
               <a:buNone/>
             </a:pPr>
             <a:r>
-              <a:rPr lang="en-US" sz="1700" b="1" dirty="0">
+              <a:rPr lang="en-US" sz="1400" b="1" dirty="0">
                 <a:solidFill>
                   <a:srgbClr val="FFB020"/>
                 </a:solidFill>
@@ -4957,7 +4978,7 @@
               </a:rPr>
               <a:t>Generic note</a:t>
             </a:r>
-            <a:endParaRPr lang="en-US" sz="1700" dirty="0"/>
+            <a:endParaRPr lang="en-US" sz="1400" dirty="0"/>
           </a:p>
         </p:txBody>
       </p:sp>
@@ -5052,7 +5073,7 @@
               <a:buNone/>
             </a:pPr>
             <a:r>
-              <a:rPr lang="en-US" sz="1700" b="1" dirty="0">
+              <a:rPr lang="en-US" sz="1400" b="1" dirty="0">
                 <a:solidFill>
                   <a:srgbClr val="FFB020"/>
                 </a:solidFill>
@@ -5062,7 +5083,7 @@
               </a:rPr>
               <a:t>Taste-file note</a:t>
             </a:r>
-            <a:endParaRPr lang="en-US" sz="1700" dirty="0"/>
+            <a:endParaRPr lang="en-US" sz="1400" dirty="0"/>
           </a:p>
         </p:txBody>
       </p:sp>
@@ -5099,7 +5120,7 @@
                 <a:ea typeface="Arial" pitchFamily="34" charset="-122"/>
                 <a:cs typeface="Arial" pitchFamily="34" charset="-120"/>
               </a:rPr>
-              <a:t>"Your taste file says funny and blunt — sentence 2 sounds like a homework robot. Say it like you'd text it."</a:t>
+              <a:t>"Section 1 says funny and blunt — sentence 2 sounds like a homework robot. Say it like you'd text a friend."</a:t>
             </a:r>
             <a:endParaRPr lang="en-US" sz="1400" dirty="0"/>
           </a:p>
@@ -5668,7 +5689,7 @@
                 <a:ea typeface="Arial" pitchFamily="34" charset="-122"/>
                 <a:cs typeface="Arial" pitchFamily="34" charset="-120"/>
               </a:rPr>
-              <a:t>Section 5 — What I'm Into Right Now: the feel of the music, shows and games you like.</a:t>
+              <a:t>Section 5 — What I'm Into Right Now: music, shows, and games. Give the feel, not the name.</a:t>
             </a:r>
             <a:endParaRPr lang="en-US" sz="1800" dirty="0"/>
           </a:p>
@@ -6309,7 +6330,7 @@
                 <a:ea typeface="Arial" pitchFamily="34" charset="-122"/>
                 <a:cs typeface="Arial" pitchFamily="34" charset="-120"/>
               </a:rPr>
-              <a:t>Swap back. Rewrite only the sentences your notes point at, plus enough around them to make it read. Star (*) every change.</a:t>
+              <a:t>Copy your draft onto page 3. Change only the sentences your notes point at, plus any word that has to change with them. Star (*) every change.</a:t>
             </a:r>
             <a:endParaRPr lang="en-US" sz="1300" dirty="0"/>
           </a:p>

</xml_diff>